<commit_message>
Prezentacja: usunięty slajdowy punkt o braku instalacji
Co-Authored-By: Claude Opus 5.5 <noreply@anthropic.com>
Claude-Session: https://claude.ai/code/session_01YZmeJVgYypM6Y2znqSmiv9
</commit_message>
<xml_diff>
--- a/game/docs/WORLD-GP-prezentacja.pptx
+++ b/game/docs/WORLD-GP-prezentacja.pptx
@@ -121,19 +121,19 @@
   <p:extLst>
     <p:ext uri="{521415D9-36F7-43E2-AB2F-B90AF26B5E84}">
       <p14:sectionLst xmlns:p14="http://schemas.microsoft.com/office/powerpoint/2010/main">
-        <p14:section name="Wstęp" id="{09fe56d3-481f-3c59-49cb-1db7003b7c8e}">
+        <p14:section name="Wstęp" id="{f362bc20-0d84-d26d-0341-decedeae5a5a}">
           <p14:sldIdLst>
             <p14:sldId id="256"/>
             <p14:sldId id="257"/>
             <p14:sldId id="258"/>
           </p14:sldIdLst>
         </p14:section>
-        <p14:section name="Uruchomienie" id="{cf13de39-6028-a39d-6ec7-3850ba650158}">
+        <p14:section name="Uruchomienie" id="{c5ce2674-39bf-371d-08ff-54b9aba4e791}">
           <p14:sldIdLst>
             <p14:sldId id="259"/>
           </p14:sldIdLst>
         </p14:section>
-        <p14:section name="Rozgrywka" id="{d300e6ad-541f-402a-5fd6-870f9735a085}">
+        <p14:section name="Rozgrywka" id="{8efe7809-35d8-4c3e-a9ba-07c5ae4d1514}">
           <p14:sldIdLst>
             <p14:sldId id="260"/>
             <p14:sldId id="261"/>
@@ -142,19 +142,19 @@
             <p14:sldId id="264"/>
           </p14:sldIdLst>
         </p14:section>
-        <p14:section name="Multiplayer" id="{ea423dca-4b2e-4aca-2f23-9c65967a7218}">
+        <p14:section name="Multiplayer" id="{fb417395-134b-3219-d8f5-b877e23b5961}">
           <p14:sldIdLst>
             <p14:sldId id="265"/>
             <p14:sldId id="266"/>
           </p14:sldIdLst>
         </p14:section>
-        <p14:section name="Ustawienia" id="{3f8d31f6-e728-eee2-3034-2086a9570df0}">
+        <p14:section name="Ustawienia" id="{f99a208d-5616-4b16-cf77-469382c12764}">
           <p14:sldIdLst>
             <p14:sldId id="267"/>
             <p14:sldId id="268"/>
           </p14:sldIdLst>
         </p14:section>
-        <p14:section name="Projekt" id="{913237f3-64b7-1e66-9ac5-925daeed63fd}">
+        <p14:section name="Projekt" id="{54313d8c-bd2c-d5da-f3d3-717376b983e6}">
           <p14:sldIdLst>
             <p14:sldId id="269"/>
             <p14:sldId id="270"/>
@@ -7397,7 +7397,7 @@
         </p:nvSpPr>
         <p:spPr>
           <a:xfrm>
-            <a:off x="548640" y="1508760"/>
+            <a:off x="548640" y="1691640"/>
             <a:ext cx="2377440" cy="685800"/>
           </a:xfrm>
           <a:prstGeom prst="rect">
@@ -7436,7 +7436,7 @@
         </p:nvSpPr>
         <p:spPr>
           <a:xfrm>
-            <a:off x="3017520" y="1673352"/>
+            <a:off x="3017520" y="1856232"/>
             <a:ext cx="2743200" cy="548640"/>
           </a:xfrm>
           <a:prstGeom prst="rect">
@@ -7472,7 +7472,7 @@
         </p:nvSpPr>
         <p:spPr>
           <a:xfrm>
-            <a:off x="548640" y="2697480"/>
+            <a:off x="548640" y="2743200"/>
             <a:ext cx="2377440" cy="685800"/>
           </a:xfrm>
           <a:prstGeom prst="rect">
@@ -7511,7 +7511,7 @@
         </p:nvSpPr>
         <p:spPr>
           <a:xfrm>
-            <a:off x="3017520" y="2862072"/>
+            <a:off x="3017520" y="2907792"/>
             <a:ext cx="2743200" cy="548640"/>
           </a:xfrm>
           <a:prstGeom prst="rect">
@@ -7547,7 +7547,7 @@
         </p:nvSpPr>
         <p:spPr>
           <a:xfrm>
-            <a:off x="548640" y="3886200"/>
+            <a:off x="548640" y="3794760"/>
             <a:ext cx="2377440" cy="685800"/>
           </a:xfrm>
           <a:prstGeom prst="rect">
@@ -7586,7 +7586,7 @@
         </p:nvSpPr>
         <p:spPr>
           <a:xfrm>
-            <a:off x="3017520" y="4050792"/>
+            <a:off x="3017520" y="3959352"/>
             <a:ext cx="2743200" cy="548640"/>
           </a:xfrm>
           <a:prstGeom prst="rect">
@@ -7614,84 +7614,9 @@
           </a:p>
         </p:txBody>
       </p:sp>
-      <p:sp>
-        <p:nvSpPr>
-          <p:cNvPr id="9" name="Liczba 4"/>
-          <p:cNvSpPr txBox="1"/>
-          <p:nvPr/>
-        </p:nvSpPr>
-        <p:spPr>
-          <a:xfrm>
-            <a:off x="548640" y="5074920"/>
-            <a:ext cx="2377440" cy="685800"/>
-          </a:xfrm>
-          <a:prstGeom prst="rect">
-            <a:avLst/>
-          </a:prstGeom>
-          <a:noFill/>
-          <a:ln/>
-        </p:spPr>
-        <p:txBody>
-          <a:bodyPr wrap="square" lIns="0" tIns="0" rIns="0" bIns="0" rtlCol="0" anchor="t"/>
-          <a:lstStyle/>
-          <a:p>
-            <a:pPr indent="0" marL="0">
-              <a:buNone/>
-            </a:pPr>
-            <a:r>
-              <a:rPr lang="en-US" sz="4000" b="1" dirty="0">
-                <a:solidFill>
-                  <a:schemeClr val="bg1"/>
-                </a:solidFill>
-                <a:latin typeface="Arial" pitchFamily="34" charset="0"/>
-                <a:ea typeface="Arial" pitchFamily="34" charset="-122"/>
-                <a:cs typeface="Arial" pitchFamily="34" charset="-120"/>
-              </a:rPr>
-              <a:t>0</a:t>
-            </a:r>
-            <a:endParaRPr lang="en-US" sz="4000" dirty="0"/>
-          </a:p>
-        </p:txBody>
-      </p:sp>
-      <p:sp>
-        <p:nvSpPr>
-          <p:cNvPr id="10" name="Opis liczby 4"/>
-          <p:cNvSpPr txBox="1"/>
-          <p:nvPr/>
-        </p:nvSpPr>
-        <p:spPr>
-          <a:xfrm>
-            <a:off x="3017520" y="5239512"/>
-            <a:ext cx="2743200" cy="548640"/>
-          </a:xfrm>
-          <a:prstGeom prst="rect">
-            <a:avLst/>
-          </a:prstGeom>
-          <a:noFill/>
-          <a:ln/>
-        </p:spPr>
-        <p:txBody>
-          <a:bodyPr wrap="square" lIns="0" tIns="0" rIns="0" bIns="0" rtlCol="0" anchor="t"/>
-          <a:lstStyle/>
-          <a:p>
-            <a:pPr indent="0" marL="0">
-              <a:buNone/>
-            </a:pPr>
-            <a:r>
-              <a:rPr lang="en-US" sz="1500" dirty="0">
-                <a:solidFill>
-                  <a:schemeClr val="bg2"/>
-                </a:solidFill>
-              </a:rPr>
-              <a:t>instalacji: HTML + JavaScript</a:t>
-            </a:r>
-            <a:endParaRPr lang="en-US" sz="1500" dirty="0"/>
-          </a:p>
-        </p:txBody>
-      </p:sp>
       <p:pic>
         <p:nvPicPr>
-          <p:cNvPr id="11" name="Menu główne" descr="/tmp/claude-0/-home-user-padok-f1/ad446ad7-6004-5edc-8614-94380b16ac33/scratchpad/doc/jpg/01-menu.jpg">    </p:cNvPr>
+          <p:cNvPr id="9" name="Menu główne" descr="/tmp/claude-0/-home-user-padok-f1/ad446ad7-6004-5edc-8614-94380b16ac33/scratchpad/doc/jpg/01-menu.jpg">    </p:cNvPr>
           <p:cNvPicPr>
             <a:picLocks noChangeAspect="1"/>
           </p:cNvPicPr>
@@ -7715,7 +7640,7 @@
       </p:pic>
       <p:sp>
         <p:nvSpPr>
-          <p:cNvPr id="12" name="Podpis menu"/>
+          <p:cNvPr id="10" name="Podpis menu"/>
           <p:cNvSpPr txBox="1"/>
           <p:nvPr/>
         </p:nvSpPr>

</xml_diff>